<commit_message>
fix: notebook via Siphon, unidades do vento, topo 200 hPa; data neutra 22/12; remove analise_sondagens.ipynb
</commit_message>
<xml_diff>
--- a/apresentacao_meso.pptx
+++ b/apresentacao_meso.pptx
@@ -628,7 +628,7 @@
           </a:p>
           <a:p>
             <a:r>
-              <a:t>2. O caso de 23/12 apresentou umidade e SBCAPE moderado (2762 J/kg), mas com cisalhamento moderado (10.2 m/s).</a:t>
+              <a:t>2. O caso de 22/12 apresentou umidade intermediária e SBCAPE moderado (836 J/kg), com inibição convectiva significativa (-221.8 J/kg).</a:t>
             </a:r>
           </a:p>
           <a:p>
@@ -832,12 +832,12 @@
           <a:p/>
           <a:p>
             <a:r>
-              <a:t>Na ANÁLISE 2 (23/12/1995 12Z):</a:t>
-            </a:r>
-          </a:p>
-          <a:p>
-            <a:r>
-              <a:t>A auditoria revelou que esta sondagem possui SBCAPE de 2761.7 J/kg e PW de 57.0 mm. Logo, ela não é rigorosamente neutra, mas sim um caso de instabilidade moderada. O cisalhamento 0-6 km é de 10.2 m/s e SRH com Left-Mover é de -54.9 m²/s². Apresentamos este resultado com transparência para avaliação do orientador.</a:t>
+              <a:t>Na ANÁLISE 2 (22/12/1995 12Z - Transição):</a:t>
+            </a:r>
+          </a:p>
+          <a:p>
+            <a:r>
+              <a:t>A sondagem de 22/12 representa a transição ideal entre o regime estável e o severo. O SBCAPE e MUCAPE são de 836.0 J/kg, acompanhados por moderada inibição convectiva (SBCIN = -221.8 J/kg) e água precipitável de 43.9 mm. O cisalhamento 0-6 km é de 2.8 m/s. Trata-se de um caso clássico de equilíbrio condicional.</a:t>
             </a:r>
           </a:p>
         </p:txBody>
@@ -1034,7 +1034,7 @@
           </a:p>
           <a:p>
             <a:r>
-              <a:t>No dia 23/12, há empuxo considerável (2536.6 J/kg pseudoadiabático e 1263.0 J/kg reversível).</a:t>
+              <a:t>No dia 22/12, há empuxo moderado (503.2 J/kg pseudoadiabático e -107.9 J/kg reversível).</a:t>
             </a:r>
           </a:p>
           <a:p>
@@ -1114,7 +1114,7 @@
           </a:p>
           <a:p>
             <a:r>
-              <a:t>No slide 6, examinamos os perfis verticais do Colab limitados ao topo de 300 hPa com legendas no topo, conforme as orientações metodológicas.</a:t>
+              <a:t>No slide 6, examinamos os perfis verticais do Colab limitados ao topo de 200 hPa com legendas no topo, conforme as orientações metodológicas.</a:t>
             </a:r>
           </a:p>
           <a:p>
@@ -1124,7 +1124,7 @@
           </a:p>
           <a:p>
             <a:r>
-              <a:t>No Painel 2, a frequência de Brunt-Väisälä (N) mostra o pico de estabilidade da tampa térmica perto de 925 hPa.</a:t>
+              <a:t>No Painel 2, a frequência de Brunt-Väisälä (N) mostra a estabilidade estática perto de 925 hPa.</a:t>
             </a:r>
           </a:p>
           <a:p>
@@ -1410,22 +1410,22 @@
           </a:p>
           <a:p>
             <a:r>
-              <a:t>No Slide 9, abordamos o monitoramento por satélite meteorológico.</a:t>
-            </a:r>
-          </a:p>
-          <a:p>
-            <a:r>
-              <a:t>A auditoria científica identificou que arquivos ISCCP-H em grade de 1° realizam médias espaciais que diluem topos de nuvens de mesoescala.</a:t>
-            </a:r>
-          </a:p>
-          <a:p>
-            <a:r>
-              <a:t>Por isso, a análise visual de satélite foi transferida para o produto de alta resolução NOAA GridSat-B1 (0,07° / ~8 km), processado no notebook analise_sondagens.ipynb.</a:t>
-            </a:r>
-          </a:p>
-          <a:p>
-            <a:r>
-              <a:t>Recomendamos demonstrar aos previsores da Defesa Civil os mapas gerados diretamente pelo notebook em 256 tons de cinza.</a:t>
+              <a:t>No Slide 9, discutimos o critério de resolução espacial no monitoramento por satélite meteorológico.</a:t>
+            </a:r>
+          </a:p>
+          <a:p>
+            <a:r>
+              <a:t>A auditoria científica identificou que arquivos em grade de 1° (como ISCCP-H, ~110 km) realizam médias espaciais que diluem topos de nuvens convectivas de mesoescala.</a:t>
+            </a:r>
+          </a:p>
+          <a:p>
+            <a:r>
+              <a:t>Topos frios de convecção severa têm escala de 5 a 20 km; ao promediar sobre uma célula de 110 km, o sinal térmico extremo é atenuado.</a:t>
+            </a:r>
+          </a:p>
+          <a:p>
+            <a:r>
+              <a:t>Ressaltamos para os previsores da Defesa Civil a importância de utilizar produtos em resolução espacial condizente com a escala dos fenômenos monitorados.</a:t>
             </a:r>
           </a:p>
         </p:txBody>
@@ -4760,7 +4760,7 @@
             </a:r>
             <a:br/>
             <a:r>
-              <a:t>2. Transição: 23/12/1995 12Z</a:t>
+              <a:t>2. Transição: 22/12/1995 12Z</a:t>
             </a:r>
             <a:br/>
             <a:r>
@@ -4871,7 +4871,7 @@
             </a:r>
             <a:br/>
             <a:r>
-              <a:t>• Freq. Brunt-Väisälä N² e Lid</a:t>
+              <a:t>• Freq. Brunt-Väisälä N² e Estabilidade</a:t>
             </a:r>
             <a:br/>
             <a:r>
@@ -5355,7 +5355,7 @@
                   <a:srgbClr val="F87171"/>
                 </a:solidFill>
               </a:rPr>
-              <a:t>12/12: 16 | 23/12: 2762 | 24/12: 1862</a:t>
+              <a:t>12/12: 16 | 22/12: 836 | 24/12: 1862</a:t>
             </a:r>
           </a:p>
           <a:p>
@@ -5378,7 +5378,7 @@
                   <a:srgbClr val="F87171"/>
                 </a:solidFill>
               </a:rPr>
-              <a:t>12/12: 1 | 23/12: 2762 | 24/12: 7810 (Sensibilidade: 1860)</a:t>
+              <a:t>12/12: 1 | 22/12: 836 | 24/12: 7810 (Sensibilidade: 1860)</a:t>
             </a:r>
           </a:p>
           <a:p>
@@ -5401,7 +5401,7 @@
                   <a:srgbClr val="38BDF8"/>
                 </a:solidFill>
               </a:rPr>
-              <a:t>12/12: 0.0 | 23/12: 0.0 | 24/12: -186.3</a:t>
+              <a:t>12/12: 0.0 | 22/12: -221.8 | 24/12: -186.3</a:t>
             </a:r>
           </a:p>
           <a:p>
@@ -5424,7 +5424,7 @@
                   <a:srgbClr val="38BDF8"/>
                 </a:solidFill>
               </a:rPr>
-              <a:t>12/12: 35.1 mm | 23/12: 57.0 mm | 24/12: 55.4 mm</a:t>
+              <a:t>12/12: 35.1 mm | 22/12: 43.9 mm | 24/12: 55.4 mm</a:t>
             </a:r>
           </a:p>
           <a:p>
@@ -5447,7 +5447,7 @@
                   <a:srgbClr val="FBBF24"/>
                 </a:solidFill>
               </a:rPr>
-              <a:t>12/12: 9 kt | 23/12: 21 kt | 24/12: 44 kt (22.6 m/s)</a:t>
+              <a:t>12/12: 9 kt | 22/12: 9 kt | 24/12: 44 kt (22.6 m/s)</a:t>
             </a:r>
           </a:p>
           <a:p>
@@ -5470,7 +5470,7 @@
                   <a:srgbClr val="34D399"/>
                 </a:solidFill>
               </a:rPr>
-              <a:t>12/12: 13.7 m/s | 23/12: 10.2 m/s | 24/12: 12.6 m/s</a:t>
+              <a:t>12/12: 13.7 m/s | 22/12: 2.8 m/s | 24/12: 12.6 m/s</a:t>
             </a:r>
           </a:p>
           <a:p>
@@ -5493,7 +5493,7 @@
                   <a:srgbClr val="34D399"/>
                 </a:solidFill>
               </a:rPr>
-              <a:t>12/12: -52.2 | 23/12: -54.9 | 24/12: -123.3</a:t>
+              <a:t>12/12: -52.2 | 22/12: -5.2 | 24/12: -123.3</a:t>
             </a:r>
           </a:p>
           <a:p>
@@ -5516,7 +5516,7 @@
                   <a:srgbClr val="F8FAFC"/>
                 </a:solidFill>
               </a:rPr>
-              <a:t>12/12: 644 | 23/12: 531 | 24/12: 1149</a:t>
+              <a:t>12/12: 644 | 22/12: 1352 | 24/12: 1149</a:t>
             </a:r>
           </a:p>
           <a:p>
@@ -5539,7 +5539,7 @@
                   <a:srgbClr val="F8FAFC"/>
                 </a:solidFill>
               </a:rPr>
-              <a:t>12/12: 643 | 23/12: 525 | 24/12: 1097</a:t>
+              <a:t>12/12: 643 | 22/12: 1338 | 24/12: 1097</a:t>
             </a:r>
           </a:p>
           <a:p>
@@ -5562,7 +5562,7 @@
                   <a:srgbClr val="F8FAFC"/>
                 </a:solidFill>
               </a:rPr>
-              <a:t>12/12: 60.0 | 23/12: 44.8 | 24/12: 60.7</a:t>
+              <a:t>12/12: 60.0 | 22/12: 195.5 | 24/12: 60.7</a:t>
             </a:r>
           </a:p>
           <a:p>
@@ -5577,15 +5577,15 @@
               </a:defRPr>
             </a:pPr>
             <a:r>
-              <a:t>• Satélite GridSat-B1: </a:t>
+              <a:t>• Resolução de Satélite: </a:t>
             </a:r>
             <a:r>
               <a:rPr b="1">
                 <a:solidFill>
-                  <a:srgbClr val="FBBF24"/>
+                  <a:srgbClr val="94A3B8"/>
                 </a:solidFill>
               </a:rPr>
-              <a:t>[gerada pelo analise_sondagens.ipynb (alta resolução 0,07°)]</a:t>
+              <a:t>Grade de 1° ISCCP descartada por diluição espacial</a:t>
             </a:r>
           </a:p>
         </p:txBody>
@@ -6517,7 +6517,7 @@
               </a:defRPr>
             </a:pPr>
             <a:r>
-              <a:t>As Três Sondagens &amp; Três Análises: Estável (12/12) vs Transição (23/12)</a:t>
+              <a:t>As Três Sondagens &amp; Três Análises: Estável (12/12) vs Transição (22/12)</a:t>
             </a:r>
           </a:p>
         </p:txBody>
@@ -6734,7 +6734,7 @@
               </a:defRPr>
             </a:pPr>
             <a:r>
-              <a:t>ANÁLISE 2: Caso de Transição / Mod. Instável (23/12/1995 12Z)</a:t>
+              <a:t>ANÁLISE 2: Caso de Transição / Mod. Instável (22/12/1995 12Z)</a:t>
             </a:r>
           </a:p>
           <a:p>
@@ -6764,7 +6764,7 @@
               </a:defRPr>
             </a:pPr>
             <a:r>
-              <a:t>• Termodinâmica Auditada: SBCAPE = 2761.7 J/kg; MUCAPE = 2761.7 J/kg; PW = 57.0 mm.</a:t>
+              <a:t>• Termodinâmica Auditada: SBCAPE = 836.0 J/kg; MUCAPE = 836.0 J/kg; SBCIN = -221.8 J/kg; PW = 43.9 mm.</a:t>
             </a:r>
           </a:p>
           <a:p>
@@ -6779,7 +6779,7 @@
               </a:defRPr>
             </a:pPr>
             <a:r>
-              <a:t>• Emanuel (1994): CAPE reversível = 1263.0 J/kg; pseudo = 2536.6 J/kg.</a:t>
+              <a:t>• Emanuel (1994): CAPE reversível = -107.9 J/kg; pseudo = 503.2 J/kg; DCAPE máx = 195.5 J/kg.</a:t>
             </a:r>
           </a:p>
           <a:p>
@@ -6794,7 +6794,7 @@
               </a:defRPr>
             </a:pPr>
             <a:r>
-              <a:t>• Cinemática: Cisalhamento 0-6 km = 10.2 m/s (19.8 kt); SRH 0-3km LM = -54.9 m²/s².</a:t>
+              <a:t>• Cinemática: Cisalhamento 0-6 km = 2.8 m/s (5.5 kt); SRH 0-3km LM = -5.2 m²/s².</a:t>
             </a:r>
           </a:p>
           <a:p>
@@ -6809,7 +6809,7 @@
               </a:defRPr>
             </a:pPr>
             <a:r>
-              <a:t>• Nota de Classificação: O SBCAPE calculado é moderado (~2.762 J/kg). Discute-se com o orientador se este caso deve ser mantido como transição ou substituído por data puramente neutra.</a:t>
+              <a:t>• Nota de Classificação: Regime autêntico de transição: empuxo moderado (SBCAPE = 836 J/kg) com expressiva inibição convectiva (SBCIN = -221.8 J/kg) que impede convecção espontânea sem forçamento dinâmico.</a:t>
             </a:r>
           </a:p>
         </p:txBody>
@@ -7051,7 +7051,7 @@
         <p:spPr>
           <a:xfrm>
             <a:off x="731520" y="1600200"/>
-            <a:ext cx="6583680" cy="4435195"/>
+            <a:ext cx="6583680" cy="4085271"/>
           </a:xfrm>
           <a:prstGeom prst="rect">
             <a:avLst/>
@@ -7301,7 +7301,7 @@
               </a:defRPr>
             </a:pPr>
             <a:r>
-              <a:t>• • Transição (23/12): SBCAPE = 2761.7 J/kg | Shear 0-6km = 10.2 m/s</a:t>
+              <a:t>• • Transição (22/12): SBCAPE = 836.0 J/kg | Shear 0-6km = 2.8 m/s</a:t>
             </a:r>
           </a:p>
           <a:p>
@@ -7778,7 +7778,7 @@
               </a:defRPr>
             </a:pPr>
             <a:r>
-              <a:t>• 23/12 (Transição): Camada de empuxo positiva. CAPE rev = 1263.0 J/kg; pseudo = 2536.6 J/kg.</a:t>
+              <a:t>• 22/12 (Transição): Camada de empuxo positiva moderada. CAPE rev = -107.9 J/kg; pseudo = 503.2 J/kg.</a:t>
             </a:r>
           </a:p>
           <a:p>
@@ -8013,7 +8013,7 @@
               </a:defRPr>
             </a:pPr>
             <a:r>
-              <a:t>Comparação dos Três Regimes Atmosféricos em Porto Alegre (SBPA - 83971) - Topo em 300 hPa</a:t>
+              <a:t>Comparação dos Três Regimes Atmosféricos em Porto Alegre (SBPA - 83971) - Topo em 200 hPa</a:t>
             </a:r>
           </a:p>
         </p:txBody>
@@ -8135,7 +8135,7 @@
               </a:defRPr>
             </a:pPr>
             <a:r>
-              <a:t>• Superfície: 12/12 = 319.3 K | 23/12 = 346.3 K | 24/12 = 377.8 K (em 925 hPa).</a:t>
+              <a:t>• Superfície: 12/12 = 319.3 K | 22/12 = 343.8 K | 24/12 = 377.8 K (em 925 hPa).</a:t>
             </a:r>
           </a:p>
           <a:p>
@@ -8150,7 +8150,7 @@
               </a:defRPr>
             </a:pPr>
             <a:r>
-              <a:t>• Instabilidade Convectiva: Camada com ∂θe/∂z &lt; 0 bem estabelecida nos dias 23 e 24/12.</a:t>
+              <a:t>• Instabilidade Convectiva: Camada com ∂θe/∂z &lt; 0 bem estabelecida nos dias 22 e 24/12.</a:t>
             </a:r>
           </a:p>
           <a:p>
@@ -9469,7 +9469,7 @@
               </a:defRPr>
             </a:pPr>
             <a:r>
-              <a:t>Monitoramento por Satélite: Imagem Infravermelho (IR)</a:t>
+              <a:t>Monitoramento por Satélite: Resolução Espacial</a:t>
             </a:r>
           </a:p>
         </p:txBody>
@@ -9504,7 +9504,7 @@
               </a:defRPr>
             </a:pPr>
             <a:r>
-              <a:t>Alta Resolução Espacial (GridSat-B1 0,07°) vs Médias em Grade de 1°</a:t>
+              <a:t>Limitações da Grade de 1° (ISCCP) vs Necessidades de Mesoescala</a:t>
             </a:r>
           </a:p>
         </p:txBody>
@@ -9584,7 +9584,7 @@
               </a:defRPr>
             </a:pPr>
             <a:r>
-              <a:t>🛰️ MONITORAMENTO POR SATÉLITE EM MESOESCALA</a:t>
+              <a:t>🛰️ RESOLUÇÃO ESPACIAL EM SATÉLITE E MESOESCALA</a:t>
             </a:r>
           </a:p>
           <a:p>
@@ -9599,29 +9599,25 @@
               </a:defRPr>
             </a:pPr>
             <a:r>
-              <a:t>[imagem IR GridSat-B1 0,07° — gerada pelo analise_sondagens.ipynb]</a:t>
+              <a:t>Limitação Física e Espacial de Grades Climatológicas:</a:t>
             </a:r>
             <a:br/>
             <a:br/>
             <a:r>
-              <a:t>Auditoria de Integridade Científica:</a:t>
+              <a:t>• A grade ISCCP-H de 1° (~110 km) promedia a temperatura de brilho sobre áreas muito superiores às células convectivas individuais.</a:t>
             </a:r>
             <a:br/>
             <a:r>
-              <a:t>• A grade ISCCP-H de 1° foi removida por tratar-se de média espacial grosseira (~110 km), inadequada para resolver topos convectivos de mesoescala.</a:t>
-            </a:r>
-            <a:br/>
-            <a:r>
-              <a:t>• O processamento oficial com alta resolução espacial (~0,07° / ~8 km) foi implementado diretamente no notebook analise_sondagens.ipynb a partir do acervo NOAA GridSat-B1.</a:t>
+              <a:t>• Topos de nuvens com convecção profunda e temperaturas de brilho inferiores a -60 °C são diluídos quando integrados com áreas vizinhas sem nuvens, mascarando a severidade real do sistema.</a:t>
             </a:r>
             <a:br/>
             <a:br/>
             <a:r>
-              <a:t>Diretriz Didática e Operacional:</a:t>
+              <a:t>Critério de Validação Operacional:</a:t>
             </a:r>
             <a:br/>
             <a:r>
-              <a:t>• Apresentar aos previsores da Defesa Civil de SC os mapas de satélite gerados diretamente pelo notebook interativo em escala padrão de cinza.</a:t>
+              <a:t>• Para monitoramento em mesoescala e defesa civil, produtos de resolução fina (como GOES em ~0,07° / ~8 km ou sensores modernos em 2 km) são indispensáveis para detectar núcleos ascendentes e overshooting tops.</a:t>
             </a:r>
           </a:p>
         </p:txBody>
@@ -9704,7 +9700,7 @@
               </a:defRPr>
             </a:pPr>
             <a:r>
-              <a:t>Base de Satélite de Alta Resolução:</a:t>
+              <a:t>Impacto da Resolução Espacial:</a:t>
             </a:r>
           </a:p>
           <a:p>
@@ -9719,7 +9715,7 @@
               </a:defRPr>
             </a:pPr>
             <a:r>
-              <a:t>• Sensor: Imager GOES-8 (Canal 4 - IR 11 µm).</a:t>
+              <a:t>• Grades de 1° (~110 km): realizam média espacial que suaviza extremos térmicos.</a:t>
             </a:r>
           </a:p>
           <a:p>
@@ -9734,7 +9730,7 @@
               </a:defRPr>
             </a:pPr>
             <a:r>
-              <a:t>• Produto: NOAA GridSat-B1 CDR (resolução espacial de 0,07° / ~8 km).</a:t>
+              <a:t>• Diluição de topos: topos convectivos frios perdem contraste térmico.</a:t>
             </a:r>
           </a:p>
           <a:p>
@@ -9749,7 +9745,7 @@
               </a:defRPr>
             </a:pPr>
             <a:r>
-              <a:t>• Paleta: Escala operacional padrão de 256 níveis de cinza (Preto = Quente | Branco = Frio).</a:t>
+              <a:t>• Subestimação do topo: mascara convecção penetrativa e severidade.</a:t>
             </a:r>
           </a:p>
           <a:p>
@@ -9764,7 +9760,7 @@
               </a:defRPr>
             </a:pPr>
             <a:r>
-              <a:t>Processamento no Notebook:</a:t>
+              <a:t>Escalas Fenomenológicas:</a:t>
             </a:r>
           </a:p>
           <a:p>
@@ -9779,7 +9775,7 @@
               </a:defRPr>
             </a:pPr>
             <a:r>
-              <a:t>• O script correspondente no notebook analise_sondagens.ipynb processa os arquivos NetCDF do GridSat-B1.</a:t>
+              <a:t>• Células convectivas: escala horizontal típica de 5 a 20 km.</a:t>
             </a:r>
           </a:p>
           <a:p>
@@ -9794,7 +9790,22 @@
               </a:defRPr>
             </a:pPr>
             <a:r>
-              <a:t>• Permite inspeção pixel a pixel da temperatura de brilho sem suavizações espaciais artificiais.</a:t>
+              <a:t>• Complexos Convectivos de Mesoescala (CCM): escala meso-alfa (&gt; 100 km), mas núcleos ativos concentrados.</a:t>
+            </a:r>
+          </a:p>
+          <a:p>
+            <a:pPr>
+              <a:spcBef>
+                <a:spcPts val="200"/>
+              </a:spcBef>
+              <a:defRPr sz="900">
+                <a:solidFill>
+                  <a:srgbClr val="F8FAFC"/>
+                </a:solidFill>
+              </a:defRPr>
+            </a:pPr>
+            <a:r>
+              <a:t>• Resolução necessária: produtos de alta resolução (≤ 8 km / 0,07°) para resolver núcleos.</a:t>
             </a:r>
           </a:p>
           <a:p>
@@ -9809,7 +9820,7 @@
               </a:defRPr>
             </a:pPr>
             <a:r>
-              <a:t>Recomendação para a Defesa Civil de SC:</a:t>
+              <a:t>Diretriz para a Defesa Civil de SC:</a:t>
             </a:r>
           </a:p>
           <a:p>
@@ -9824,7 +9835,22 @@
               </a:defRPr>
             </a:pPr>
             <a:r>
-              <a:t>• Para monitoramento em tempo real e estudos de caso de tempo severo, privilegiar produtos de satélite com resolução adequada à escala das células convectivas.</a:t>
+              <a:t>• Não utilizar produtos de grade climatológica grosseira para diagnóstico de eventos severos.</a:t>
+            </a:r>
+          </a:p>
+          <a:p>
+            <a:pPr>
+              <a:spcBef>
+                <a:spcPts val="200"/>
+              </a:spcBef>
+              <a:defRPr sz="900">
+                <a:solidFill>
+                  <a:srgbClr val="F8FAFC"/>
+                </a:solidFill>
+              </a:defRPr>
+            </a:pPr>
+            <a:r>
+              <a:t>• Privilegiar canais infravermelho de alta taxa temporal e espacial para emissão de alertas precoces.</a:t>
             </a:r>
           </a:p>
         </p:txBody>

</xml_diff>

<commit_message>
Limpa metpack e explica uv, Miniconda e MATLAB Online no ROTEIRO
- Remove de metpack/ o que não deve estar no repositório: saídas geradas pelo wyoming.f
  (*.out, modsound, header, sounding*.txt de trabalho), o wyoming.exe, autosaves do MATLAB (.asv),
  os dados e o script do satélite ISCCP de 1°, web_soundings_data.json, soundings_RF6.mat,
  o Leiame duplicado e os scripts Python antigos substituídos (getsounding.py, tcon.py, wyoming.py).
- calc_metricas.py lê o cape.out das pastas emanuel_* gravadas pelo notebook.
- .gitignore impede que essas saídas voltem.
- ROTEIRO: novo item 3.0 (Colab, uv, Miniconda, MATLAB Online e gfortran: o que são e onde baixar);
  Opção B também com Miniconda; retira o item 2.3 (wyoming.py).
- README e metpack/README atualizados para os arquivos que ficaram.

Co-Authored-By: Claude Opus 5.5 <noreply@anthropic.com>
Claude-Session: https://claude.ai/code/session_01MrjxF8AvJ475HLzyBj1rWQ
</commit_message>
<xml_diff>
--- a/apresentacao_meso.pptx
+++ b/apresentacao_meso.pptx
@@ -1013,7 +1013,7 @@
           </a:p>
           <a:p>
             <a:r>
-              <a:t>À esquerda, temos os gráficos 2D gerados pelas rotinas wyoming.f / tcon.py para as três radiossondagens.</a:t>
+              <a:t>À esquerda, temos os gráficos 2D gerados pelas rotinas wyoming.f / tcon_emanuel.py para as três radiossondagens.</a:t>
             </a:r>
           </a:p>
           <a:p>
@@ -5775,7 +5775,7 @@
             <a:br/>
             <a:br/>
             <a:r>
-              <a:t>O código-fonte completo (wyoming.py, tcon.py, calc_metricas.py, plot_sat_ir.py, generate_figures.py e tutorial interativo) encontra-se disponível no repositório GitHub:</a:t>
+              <a:t>O código-fonte completo (notebook, wyoming.f, tarefa_sondagens.py/.m, calc_metricas.py, generate_figures.py e tutorial interativo) encontra-se disponível no repositório GitHub:</a:t>
             </a:r>
             <a:br/>
             <a:r>
@@ -7688,7 +7688,7 @@
               </a:defRPr>
             </a:pPr>
             <a:r>
-              <a:t>• Algoritmo: rotinas wyoming.f / tcon.py calculando matrizes tdifrev (Tρ) e tdifpseudo (Tv).</a:t>
+              <a:t>• Algoritmo: rotinas wyoming.f / tcon_emanuel.py calculando matrizes tdifrev (Tρ) e tdifpseudo (Tv).</a:t>
             </a:r>
           </a:p>
           <a:p>

</xml_diff>